<commit_message>
streamlit live trading page update
</commit_message>
<xml_diff>
--- a/docs/options-agent-strategy.pptx
+++ b/docs/options-agent-strategy.pptx
@@ -1796,7 +1796,7 @@
           <a:p>
             <a:r>
               <a:rPr lang="en-US" dirty="0"/>
-              <a:t>0:25-1:20. Not three variations on one idea - deliberately opposite. Carry sells movement and wants nothing to happen; intraday buys continuation and wants something fast. One short vol, one long vol, so a week that kills one is often good for the other. Events exists because of a specific failure: the other books wait for a threshold that never crosses. Here the entry condition is a DATE.</a:t>
+              <a:t>0:18-0:52. Not three variations on one idea - deliberately opposite. Carry sells movement and wants nothing to happen; intraday buys continuation and wants something fast. One short vol, one long vol, so a week that kills one is often good for the other. Events exists because of a specific failure: the other books wait for a threshold that never crosses. Here the entry condition is a DATE.</a:t>
             </a:r>
             <a:endParaRPr lang="en-US" dirty="0"/>
           </a:p>
@@ -1884,7 +1884,7 @@
           <a:p>
             <a:r>
               <a:rPr lang="en-US" dirty="0"/>
-              <a:t>If asked for detail on any one book, the appendix has a full slide per book plus every parameter with the measurement behind it.1:20-2:20. Hard gates, not a score - a score lets a rich IV reading paper over an earnings date. Land the closing point: every threshold here was moved by measurement. IV floor 0.70 rejected 304 of 304. Intraday spread ceiling 2% was below the tightest quote in the universe. Eight stacked vetoes = 0.7^8 = 6%: eight vetoes in a row is not a strategy.</a:t>
+              <a:t>If asked for detail on any one book, the appendix has a full slide per book plus every parameter with the measurement behind it.0:52-1:35. Hard gates, not a score - a score lets a rich IV reading paper over an earnings date. Land the closing point: every threshold here was moved by measurement. IV floor 0.70 rejected 304 of 304. Intraday spread ceiling 2% was below the tightest quote in the universe. Eight stacked vetoes = 0.7^8 = 6%: eight vetoes in a row is not a strategy.</a:t>
             </a:r>
             <a:endParaRPr lang="en-US" dirty="0"/>
           </a:p>
@@ -1972,7 +1972,7 @@
           <a:p>
             <a:r>
               <a:rPr lang="en-US" dirty="0"/>
-              <a:t>2:20-3:10. Same stages live and in replay, from the same objects. Critic declines but cannot approve; the events LLM cannot either. Stage 4 signs the ticket. The two gold checks exist because brokers NET identical option symbols - re-opening the same condor doubles one position rather than creating a second, so every count-based limit was blind to it. Sizing from max loss, not capital. 15:15 liquidates transient books and polls until confirmed flat.</a:t>
+              <a:t>1:35-2:10. Same stages live and in replay, from the same objects. Critic declines but cannot approve; the events LLM cannot either. Stage 4 signs the ticket. The two gold checks exist because brokers NET identical option symbols - re-opening the same condor doubles one position rather than creating a second, so every count-based limit was blind to it. Sizing from max loss, not capital. 15:15 liquidates transient books and polls until confirmed flat.</a:t>
             </a:r>
             <a:endParaRPr lang="en-US" dirty="0"/>
           </a:p>
@@ -2060,7 +2060,7 @@
           <a:p>
             <a:r>
               <a:rPr lang="en-US" dirty="0"/>
-              <a:t>3:10-4:10. Read the red number: gross $13,973 against $12,990 of spread - the book paid out roughly its own gross profit in execution cost, WITH a cost gate in front of every trade. The bars say the exits are the strategy. Short-strike touches are the cost of keeping a defined-risk structure defined. Intraday stop is wider than target on purpose and you can see the price: 75 wins at +$139 vs 43 stops at -$244. Say the split out loud - carry carries it, intraday lost $5,018, events has no usable backtest.</a:t>
+              <a:t>2:10-2:55. Read the red number: gross $13,973 against $12,990 of spread - the book paid out roughly its own gross profit in execution cost, WITH a cost gate in front of every trade. The bars say the exits are the strategy. Short-strike touches are the cost of keeping a defined-risk structure defined. Intraday stop is wider than target on purpose and you can see the price: 75 wins at +$139 vs 43 stops at -$244. Say the split out loud - carry carries it, intraday lost $5,018, events has no usable backtest.</a:t>
             </a:r>
             <a:endParaRPr lang="en-US" dirty="0"/>
           </a:p>
@@ -2148,7 +2148,7 @@
           <a:p>
             <a:r>
               <a:rPr lang="en-US" dirty="0"/>
-              <a:t>4:10-5:00. Four measured defects, all in the repo. Then the claim: the agent's job is to decline. 8,569 ideas, 441 taken, 72,753 rejections each logged with the gate and the number. Gates are hard, no model can approve, every number is defended - including the ones that are still guesses, which say so. Offer the appendix.</a:t>
+              <a:t>2:55-3:30. Four measured defects, all in the repo. Then the claim: the agent's job is to decline. 8,569 ideas, 441 taken, 72,753 rejections each logged with the gate and the number. Gates are hard, no model can approve, every number is defended - including the ones that are still guesses, which say so. Offer the appendix.</a:t>
             </a:r>
             <a:endParaRPr lang="en-US" dirty="0"/>
           </a:p>

</xml_diff>